<commit_message>
Add roai.emergedigital.ae custom domain + migrate collateral to it
- wrangler.toml: workers_dev = true (keep *.workers.dev as fallback). The
  roai.emergedigital.ae custom domain is attached to the Worker out-of-band
  (created via `wrangler deploy`); it persists without being in config, so the
  route is intentionally NOT committed here — that keeps the CI deploy token free
  of DNS-scope requirements.
- public/guide.html + scripts/build-explainers.py + rebuilt deck/PDF: all
  absolute links now point at https://roai.emergedigital.ae (download links remain
  relative, so they work on either domain).

Co-Authored-By: Claude Opus 4.8 (1M context) <noreply@anthropic.com>
</commit_message>
<xml_diff>
--- a/public/downloads/Vela-OS-Demo-Deck.pptx
+++ b/public/downloads/Vela-OS-Demo-Deck.pptx
@@ -4219,7 +4219,7 @@
                 </a:solidFill>
                 <a:latin typeface="Arial"/>
               </a:rPr>
-              <a:t>vela-os-roai.emerge-digital.workers.dev</a:t>
+              <a:t>roai.emergedigital.ae</a:t>
             </a:r>
           </a:p>
         </p:txBody>
@@ -4868,7 +4868,7 @@
                 </a:solidFill>
                 <a:latin typeface="Arial"/>
               </a:rPr>
-              <a:t>vela-os-roai.emerge-digital.workers.dev</a:t>
+              <a:t>roai.emergedigital.ae</a:t>
             </a:r>
           </a:p>
         </p:txBody>
@@ -5955,7 +5955,7 @@
                 </a:solidFill>
                 <a:latin typeface="Arial"/>
               </a:rPr>
-              <a:t>vela-os-roai.emerge-digital.workers.dev</a:t>
+              <a:t>roai.emergedigital.ae</a:t>
             </a:r>
           </a:p>
         </p:txBody>
@@ -6462,7 +6462,7 @@
                 </a:solidFill>
                 <a:latin typeface="Arial"/>
               </a:rPr>
-              <a:t>vela-os-roai.emerge-digital.workers.dev</a:t>
+              <a:t>roai.emergedigital.ae</a:t>
             </a:r>
           </a:p>
         </p:txBody>
@@ -7072,7 +7072,7 @@
                 </a:solidFill>
                 <a:latin typeface="Arial"/>
               </a:rPr>
-              <a:t>vela-os-roai.emerge-digital.workers.dev</a:t>
+              <a:t>roai.emergedigital.ae</a:t>
             </a:r>
           </a:p>
         </p:txBody>
@@ -8194,7 +8194,7 @@
                 </a:solidFill>
                 <a:latin typeface="Arial"/>
               </a:rPr>
-              <a:t>vela-os-roai.emerge-digital.workers.dev</a:t>
+              <a:t>roai.emergedigital.ae</a:t>
             </a:r>
           </a:p>
         </p:txBody>
@@ -9509,7 +9509,7 @@
                 </a:solidFill>
                 <a:latin typeface="Arial"/>
               </a:rPr>
-              <a:t>https://vela-os-roai.emerge-digital.workers.dev/guide</a:t>
+              <a:t>https://roai.emergedigital.ae/guide</a:t>
             </a:r>
           </a:p>
         </p:txBody>
@@ -9596,7 +9596,7 @@
                 </a:solidFill>
                 <a:latin typeface="Arial"/>
               </a:rPr>
-              <a:t>vela-os-roai.emerge-digital.workers.dev</a:t>
+              <a:t>roai.emergedigital.ae</a:t>
             </a:r>
           </a:p>
         </p:txBody>
@@ -9913,7 +9913,7 @@
                 </a:solidFill>
                 <a:latin typeface="Arial"/>
               </a:rPr>
-              <a:t>vela-os-roai.emerge-digital.workers.dev</a:t>
+              <a:t>roai.emergedigital.ae</a:t>
             </a:r>
           </a:p>
         </p:txBody>
@@ -10007,7 +10007,7 @@
                 </a:solidFill>
                 <a:latin typeface="Arial"/>
               </a:rPr>
-              <a:t>vela-os-roai.emerge-digital.workers.dev/guide</a:t>
+              <a:t>roai.emergedigital.ae/guide</a:t>
             </a:r>
           </a:p>
         </p:txBody>

</xml_diff>

<commit_message>
collateral: regenerate one-pager + demo deck on vela.emergedigital.com
build-explainers.py rerun after the domain cutover (LIVE constant changed in
#65). PDF text extraction: 4 vela refs / 0 roai; PPTX slides: 9 / 0. Note the
plan's `strings`-on-PDF check is invalid — fpdf compresses text streams; use
pypdf extraction instead.

Co-Authored-By: Claude Fable 5 <noreply@anthropic.com>
</commit_message>
<xml_diff>
--- a/public/downloads/Vela-OS-Demo-Deck.pptx
+++ b/public/downloads/Vela-OS-Demo-Deck.pptx
@@ -3899,7 +3899,7 @@
                 </a:solidFill>
                 <a:latin typeface="Arial"/>
               </a:rPr>
-              <a:t>roai.emergedigital.ae</a:t>
+              <a:t>vela.emergedigital.com</a:t>
             </a:r>
           </a:p>
         </p:txBody>
@@ -3993,7 +3993,7 @@
                 </a:solidFill>
                 <a:latin typeface="Arial"/>
               </a:rPr>
-              <a:t>roai.emergedigital.ae/guide</a:t>
+              <a:t>vela.emergedigital.com/guide</a:t>
             </a:r>
           </a:p>
         </p:txBody>
@@ -4670,7 +4670,7 @@
                 </a:solidFill>
                 <a:latin typeface="Arial"/>
               </a:rPr>
-              <a:t>roai.emergedigital.ae</a:t>
+              <a:t>vela.emergedigital.com</a:t>
             </a:r>
           </a:p>
         </p:txBody>
@@ -5319,7 +5319,7 @@
                 </a:solidFill>
                 <a:latin typeface="Arial"/>
               </a:rPr>
-              <a:t>roai.emergedigital.ae</a:t>
+              <a:t>vela.emergedigital.com</a:t>
             </a:r>
           </a:p>
         </p:txBody>
@@ -6406,7 +6406,7 @@
                 </a:solidFill>
                 <a:latin typeface="Arial"/>
               </a:rPr>
-              <a:t>roai.emergedigital.ae</a:t>
+              <a:t>vela.emergedigital.com</a:t>
             </a:r>
           </a:p>
         </p:txBody>
@@ -7487,7 +7487,7 @@
                 </a:solidFill>
                 <a:latin typeface="Arial"/>
               </a:rPr>
-              <a:t>roai.emergedigital.ae</a:t>
+              <a:t>vela.emergedigital.com</a:t>
             </a:r>
           </a:p>
         </p:txBody>
@@ -7994,7 +7994,7 @@
                 </a:solidFill>
                 <a:latin typeface="Arial"/>
               </a:rPr>
-              <a:t>roai.emergedigital.ae</a:t>
+              <a:t>vela.emergedigital.com</a:t>
             </a:r>
           </a:p>
         </p:txBody>
@@ -8604,7 +8604,7 @@
                 </a:solidFill>
                 <a:latin typeface="Arial"/>
               </a:rPr>
-              <a:t>roai.emergedigital.ae</a:t>
+              <a:t>vela.emergedigital.com</a:t>
             </a:r>
           </a:p>
         </p:txBody>
@@ -9735,7 +9735,7 @@
                 </a:solidFill>
                 <a:latin typeface="Arial"/>
               </a:rPr>
-              <a:t>roai.emergedigital.ae</a:t>
+              <a:t>vela.emergedigital.com</a:t>
             </a:r>
           </a:p>
         </p:txBody>
@@ -11089,7 +11089,7 @@
                 </a:solidFill>
                 <a:latin typeface="Arial"/>
               </a:rPr>
-              <a:t>https://roai.emergedigital.ae/guide</a:t>
+              <a:t>https://vela.emergedigital.com/guide</a:t>
             </a:r>
           </a:p>
         </p:txBody>
@@ -11176,7 +11176,7 @@
                 </a:solidFill>
                 <a:latin typeface="Arial"/>
               </a:rPr>
-              <a:t>roai.emergedigital.ae</a:t>
+              <a:t>vela.emergedigital.com</a:t>
             </a:r>
           </a:p>
         </p:txBody>

</xml_diff>

<commit_message>
collateral: regenerate one-pager + demo deck on vela.emergedigital.com (#67)
build-explainers.py rerun after the domain cutover (LIVE constant changed in
#65). PDF text extraction: 4 vela refs / 0 roai; PPTX slides: 9 / 0. Note the
plan's `strings`-on-PDF check is invalid — fpdf compresses text streams; use
pypdf extraction instead.

Co-authored-by: Claude Fable 5 <noreply@anthropic.com>
</commit_message>
<xml_diff>
--- a/public/downloads/Vela-OS-Demo-Deck.pptx
+++ b/public/downloads/Vela-OS-Demo-Deck.pptx
@@ -3899,7 +3899,7 @@
                 </a:solidFill>
                 <a:latin typeface="Arial"/>
               </a:rPr>
-              <a:t>roai.emergedigital.ae</a:t>
+              <a:t>vela.emergedigital.com</a:t>
             </a:r>
           </a:p>
         </p:txBody>
@@ -3993,7 +3993,7 @@
                 </a:solidFill>
                 <a:latin typeface="Arial"/>
               </a:rPr>
-              <a:t>roai.emergedigital.ae/guide</a:t>
+              <a:t>vela.emergedigital.com/guide</a:t>
             </a:r>
           </a:p>
         </p:txBody>
@@ -4670,7 +4670,7 @@
                 </a:solidFill>
                 <a:latin typeface="Arial"/>
               </a:rPr>
-              <a:t>roai.emergedigital.ae</a:t>
+              <a:t>vela.emergedigital.com</a:t>
             </a:r>
           </a:p>
         </p:txBody>
@@ -5319,7 +5319,7 @@
                 </a:solidFill>
                 <a:latin typeface="Arial"/>
               </a:rPr>
-              <a:t>roai.emergedigital.ae</a:t>
+              <a:t>vela.emergedigital.com</a:t>
             </a:r>
           </a:p>
         </p:txBody>
@@ -6406,7 +6406,7 @@
                 </a:solidFill>
                 <a:latin typeface="Arial"/>
               </a:rPr>
-              <a:t>roai.emergedigital.ae</a:t>
+              <a:t>vela.emergedigital.com</a:t>
             </a:r>
           </a:p>
         </p:txBody>
@@ -7487,7 +7487,7 @@
                 </a:solidFill>
                 <a:latin typeface="Arial"/>
               </a:rPr>
-              <a:t>roai.emergedigital.ae</a:t>
+              <a:t>vela.emergedigital.com</a:t>
             </a:r>
           </a:p>
         </p:txBody>
@@ -7994,7 +7994,7 @@
                 </a:solidFill>
                 <a:latin typeface="Arial"/>
               </a:rPr>
-              <a:t>roai.emergedigital.ae</a:t>
+              <a:t>vela.emergedigital.com</a:t>
             </a:r>
           </a:p>
         </p:txBody>
@@ -8604,7 +8604,7 @@
                 </a:solidFill>
                 <a:latin typeface="Arial"/>
               </a:rPr>
-              <a:t>roai.emergedigital.ae</a:t>
+              <a:t>vela.emergedigital.com</a:t>
             </a:r>
           </a:p>
         </p:txBody>
@@ -9735,7 +9735,7 @@
                 </a:solidFill>
                 <a:latin typeface="Arial"/>
               </a:rPr>
-              <a:t>roai.emergedigital.ae</a:t>
+              <a:t>vela.emergedigital.com</a:t>
             </a:r>
           </a:p>
         </p:txBody>
@@ -11089,7 +11089,7 @@
                 </a:solidFill>
                 <a:latin typeface="Arial"/>
               </a:rPr>
-              <a:t>https://roai.emergedigital.ae/guide</a:t>
+              <a:t>https://vela.emergedigital.com/guide</a:t>
             </a:r>
           </a:p>
         </p:txBody>
@@ -11176,7 +11176,7 @@
                 </a:solidFill>
                 <a:latin typeface="Arial"/>
               </a:rPr>
-              <a:t>roai.emergedigital.ae</a:t>
+              <a:t>vela.emergedigital.com</a:t>
             </a:r>
           </a:p>
         </p:txBody>

</xml_diff>